<commit_message>
W03 SAT passes 2 and 3 and the humanizer read: the presentation deck says what Kalpa Health is and how it bills, defines payer and phlebotomist, and rewrites its contrast tails as plain statements; the week close says what Kalpa Health is; the TRAINER files lose their decorative rules and two restating closers; both decks rebuilt; the provenance records the sources, the three real-world facts checked on 1 October 2026, the plants and where each is used, every invention, the decisions, where the files differ from the spine, the tool versions and passes 1 to 3
Co-Authored-By: Claude Opus 5.5 <noreply@anthropic.com>
Claude-Session: https://claude.ai/code/session_01VFn7PXPJsRCn9QfcoxZL6T
</commit_message>
<xml_diff>
--- a/content/W03/SAT/slides/C2_W03_SAT_week_close_STUDENT.pptx
+++ b/content/W03/SAT/slides/C2_W03_SAT_week_close_STUDENT.pptx
@@ -697,7 +697,7 @@
           </a:p>
           <a:p>
             <a:r>
-              <a:t>rewrite, never an argument.</a:t>
+              <a:t>rewrite and move on.</a:t>
             </a:r>
           </a:p>
           <a:p>
@@ -12741,7 +12741,7 @@
         <p:spPr>
           <a:xfrm>
             <a:off x="530352" y="3474720"/>
-            <a:ext cx="11130991" cy="772160"/>
+            <a:ext cx="11130991" cy="1048512"/>
           </a:xfrm>
           <a:prstGeom prst="rect">
             <a:avLst/>
@@ -12766,7 +12766,7 @@
                 </a:solidFill>
                 <a:latin typeface="Calibri"/>
               </a:rPr>
-              <a:t>Each group's answer to Dr Menon is its own one-slide answer, said to the panel today; these fifteen minutes are about the method that produced it.</a:t>
+              <a:t>Kalpa Health is the US diagnostics business the week was built on; each group's answer to its COO, Dr Menon, is its own one-slide answer, said to the panel today, and these fifteen minutes are about the method behind it.</a:t>
             </a:r>
           </a:p>
         </p:txBody>

</xml_diff>